<commit_message>
Fix PPT generation path to target docs/ directory
</commit_message>
<xml_diff>
--- a/docs/Elevate_HR_Team_12_Autonomous_MAS_Presentation.pptx
+++ b/docs/Elevate_HR_Team_12_Autonomous_MAS_Presentation.pptx
@@ -7056,7 +7056,7 @@
               </a:defRPr>
             </a:pPr>
             <a:r>
-              <a:t>AUTONOMOUS EXECUTION FLOW</a:t>
+              <a:t>ARCHITECTURE FLOW</a:t>
             </a:r>
           </a:p>
           <a:p>
@@ -7068,45 +7068,457 @@
               </a:defRPr>
             </a:pPr>
             <a:r>
-              <a:t>Compound Multi-Hop Workflow Delegation</a:t>
-            </a:r>
-          </a:p>
-        </p:txBody>
-      </p:sp>
-      <p:pic>
-        <p:nvPicPr>
-          <p:cNvPr id="3" name="Picture 2" descr="flow_diagram_1786964693259.jpg"/>
-          <p:cNvPicPr>
-            <a:picLocks noChangeAspect="1"/>
-          </p:cNvPicPr>
+              <a:t>Service &amp; Agentic Execution Path</a:t>
+            </a:r>
+          </a:p>
+        </p:txBody>
+      </p:sp>
+      <p:sp>
+        <p:nvSpPr>
+          <p:cNvPr id="3" name="Rounded Rectangle 2"/>
+          <p:cNvSpPr/>
           <p:nvPr/>
-        </p:nvPicPr>
-        <p:blipFill>
-          <a:blip r:embed="rId2"/>
-          <a:stretch>
-            <a:fillRect/>
-          </a:stretch>
-        </p:blipFill>
-        <p:spPr>
-          <a:xfrm>
-            <a:off x="731520" y="1463040"/>
-            <a:ext cx="5669280" cy="3164249"/>
-          </a:xfrm>
-          <a:prstGeom prst="rect">
+        </p:nvSpPr>
+        <p:spPr>
+          <a:xfrm>
+            <a:off x="731520" y="1645920"/>
+            <a:ext cx="5029200" cy="548640"/>
+          </a:xfrm>
+          <a:prstGeom prst="roundRect">
             <a:avLst/>
           </a:prstGeom>
-        </p:spPr>
-      </p:pic>
-      <p:sp>
-        <p:nvSpPr>
-          <p:cNvPr id="4" name="Rounded Rectangle 3"/>
+          <a:solidFill>
+            <a:srgbClr val="E8F0FE"/>
+          </a:solidFill>
+          <a:ln w="19050">
+            <a:solidFill>
+              <a:srgbClr val="1A73E8"/>
+            </a:solidFill>
+          </a:ln>
+        </p:spPr>
+        <p:style>
+          <a:lnRef idx="1">
+            <a:schemeClr val="accent1"/>
+          </a:lnRef>
+          <a:fillRef idx="3">
+            <a:schemeClr val="accent1"/>
+          </a:fillRef>
+          <a:effectRef idx="2">
+            <a:schemeClr val="accent1"/>
+          </a:effectRef>
+          <a:fontRef idx="minor">
+            <a:schemeClr val="lt1"/>
+          </a:fontRef>
+        </p:style>
+        <p:txBody>
+          <a:bodyPr rtlCol="0" anchor="ctr" wrap="square"/>
+          <a:lstStyle/>
+          <a:p>
+            <a:pPr algn="ctr">
+              <a:defRPr sz="1100" b="1">
+                <a:solidFill>
+                  <a:srgbClr val="1E293B"/>
+                </a:solidFill>
+              </a:defRPr>
+            </a:pPr>
+            <a:r>
+              <a:t>User Request -&gt; API Gateway &amp; Identity Bridge</a:t>
+            </a:r>
+          </a:p>
+        </p:txBody>
+      </p:sp>
+      <p:sp>
+        <p:nvSpPr>
+          <p:cNvPr id="4" name="Diamond 3"/>
           <p:cNvSpPr/>
           <p:nvPr/>
         </p:nvSpPr>
         <p:spPr>
           <a:xfrm>
-            <a:off x="6675120" y="1463040"/>
-            <a:ext cx="4754880" cy="1097280"/>
+            <a:off x="2560320" y="2377440"/>
+            <a:ext cx="1371600" cy="548640"/>
+          </a:xfrm>
+          <a:prstGeom prst="diamond">
+            <a:avLst/>
+          </a:prstGeom>
+          <a:solidFill>
+            <a:srgbClr val="FBBC05"/>
+          </a:solidFill>
+          <a:ln w="19050">
+            <a:solidFill>
+              <a:srgbClr val="1A73E8"/>
+            </a:solidFill>
+          </a:ln>
+        </p:spPr>
+        <p:style>
+          <a:lnRef idx="1">
+            <a:schemeClr val="accent1"/>
+          </a:lnRef>
+          <a:fillRef idx="3">
+            <a:schemeClr val="accent1"/>
+          </a:fillRef>
+          <a:effectRef idx="2">
+            <a:schemeClr val="accent1"/>
+          </a:effectRef>
+          <a:fontRef idx="minor">
+            <a:schemeClr val="lt1"/>
+          </a:fontRef>
+        </p:style>
+        <p:txBody>
+          <a:bodyPr rtlCol="0" anchor="ctr" wrap="square"/>
+          <a:lstStyle/>
+          <a:p>
+            <a:pPr algn="ctr">
+              <a:defRPr sz="1100" b="1">
+                <a:solidFill>
+                  <a:srgbClr val="1E293B"/>
+                </a:solidFill>
+              </a:defRPr>
+            </a:pPr>
+            <a:r>
+              <a:t>Model Armor (Safe?)</a:t>
+            </a:r>
+          </a:p>
+        </p:txBody>
+      </p:sp>
+      <p:sp>
+        <p:nvSpPr>
+          <p:cNvPr id="5" name="Rounded Rectangle 4"/>
+          <p:cNvSpPr/>
+          <p:nvPr/>
+        </p:nvSpPr>
+        <p:spPr>
+          <a:xfrm>
+            <a:off x="2560320" y="3200400"/>
+            <a:ext cx="1371600" cy="548640"/>
+          </a:xfrm>
+          <a:prstGeom prst="roundRect">
+            <a:avLst/>
+          </a:prstGeom>
+          <a:solidFill>
+            <a:srgbClr val="1A73E8"/>
+          </a:solidFill>
+          <a:ln w="19050">
+            <a:solidFill>
+              <a:srgbClr val="1A73E8"/>
+            </a:solidFill>
+          </a:ln>
+        </p:spPr>
+        <p:style>
+          <a:lnRef idx="1">
+            <a:schemeClr val="accent1"/>
+          </a:lnRef>
+          <a:fillRef idx="3">
+            <a:schemeClr val="accent1"/>
+          </a:fillRef>
+          <a:effectRef idx="2">
+            <a:schemeClr val="accent1"/>
+          </a:effectRef>
+          <a:fontRef idx="minor">
+            <a:schemeClr val="lt1"/>
+          </a:fontRef>
+        </p:style>
+        <p:txBody>
+          <a:bodyPr rtlCol="0" anchor="ctr" wrap="square"/>
+          <a:lstStyle/>
+          <a:p>
+            <a:pPr algn="ctr">
+              <a:defRPr sz="1100" b="1">
+                <a:solidFill>
+                  <a:srgbClr val="FFFFFF"/>
+                </a:solidFill>
+              </a:defRPr>
+            </a:pPr>
+            <a:r>
+              <a:t>hr_orchestrator</a:t>
+            </a:r>
+            <a:br/>
+            <a:r>
+              <a:t>(Router)</a:t>
+            </a:r>
+          </a:p>
+        </p:txBody>
+      </p:sp>
+      <p:sp>
+        <p:nvSpPr>
+          <p:cNvPr id="6" name="Rounded Rectangle 5"/>
+          <p:cNvSpPr/>
+          <p:nvPr/>
+        </p:nvSpPr>
+        <p:spPr>
+          <a:xfrm>
+            <a:off x="731520" y="4114800"/>
+            <a:ext cx="1371600" cy="548640"/>
+          </a:xfrm>
+          <a:prstGeom prst="roundRect">
+            <a:avLst/>
+          </a:prstGeom>
+          <a:solidFill>
+            <a:srgbClr val="E8F0FE"/>
+          </a:solidFill>
+          <a:ln w="19050">
+            <a:solidFill>
+              <a:srgbClr val="1A73E8"/>
+            </a:solidFill>
+          </a:ln>
+        </p:spPr>
+        <p:style>
+          <a:lnRef idx="1">
+            <a:schemeClr val="accent1"/>
+          </a:lnRef>
+          <a:fillRef idx="3">
+            <a:schemeClr val="accent1"/>
+          </a:fillRef>
+          <a:effectRef idx="2">
+            <a:schemeClr val="accent1"/>
+          </a:effectRef>
+          <a:fontRef idx="minor">
+            <a:schemeClr val="lt1"/>
+          </a:fontRef>
+        </p:style>
+        <p:txBody>
+          <a:bodyPr rtlCol="0" anchor="ctr" wrap="square"/>
+          <a:lstStyle/>
+          <a:p>
+            <a:pPr algn="ctr">
+              <a:defRPr sz="1100" b="1">
+                <a:solidFill>
+                  <a:srgbClr val="1E293B"/>
+                </a:solidFill>
+              </a:defRPr>
+            </a:pPr>
+            <a:r>
+              <a:t>hcm_specialist</a:t>
+            </a:r>
+          </a:p>
+        </p:txBody>
+      </p:sp>
+      <p:sp>
+        <p:nvSpPr>
+          <p:cNvPr id="7" name="Rounded Rectangle 6"/>
+          <p:cNvSpPr/>
+          <p:nvPr/>
+        </p:nvSpPr>
+        <p:spPr>
+          <a:xfrm>
+            <a:off x="2560320" y="4114800"/>
+            <a:ext cx="1371600" cy="548640"/>
+          </a:xfrm>
+          <a:prstGeom prst="roundRect">
+            <a:avLst/>
+          </a:prstGeom>
+          <a:solidFill>
+            <a:srgbClr val="E8F0FE"/>
+          </a:solidFill>
+          <a:ln w="19050">
+            <a:solidFill>
+              <a:srgbClr val="1A73E8"/>
+            </a:solidFill>
+          </a:ln>
+        </p:spPr>
+        <p:style>
+          <a:lnRef idx="1">
+            <a:schemeClr val="accent1"/>
+          </a:lnRef>
+          <a:fillRef idx="3">
+            <a:schemeClr val="accent1"/>
+          </a:fillRef>
+          <a:effectRef idx="2">
+            <a:schemeClr val="accent1"/>
+          </a:effectRef>
+          <a:fontRef idx="minor">
+            <a:schemeClr val="lt1"/>
+          </a:fontRef>
+        </p:style>
+        <p:txBody>
+          <a:bodyPr rtlCol="0" anchor="ctr" wrap="square"/>
+          <a:lstStyle/>
+          <a:p>
+            <a:pPr algn="ctr">
+              <a:defRPr sz="1100" b="1">
+                <a:solidFill>
+                  <a:srgbClr val="1E293B"/>
+                </a:solidFill>
+              </a:defRPr>
+            </a:pPr>
+            <a:r>
+              <a:t>itsm_specialist</a:t>
+            </a:r>
+          </a:p>
+        </p:txBody>
+      </p:sp>
+      <p:sp>
+        <p:nvSpPr>
+          <p:cNvPr id="8" name="Rounded Rectangle 7"/>
+          <p:cNvSpPr/>
+          <p:nvPr/>
+        </p:nvSpPr>
+        <p:spPr>
+          <a:xfrm>
+            <a:off x="4389120" y="4114800"/>
+            <a:ext cx="1371600" cy="548640"/>
+          </a:xfrm>
+          <a:prstGeom prst="roundRect">
+            <a:avLst/>
+          </a:prstGeom>
+          <a:solidFill>
+            <a:srgbClr val="E8F0FE"/>
+          </a:solidFill>
+          <a:ln w="19050">
+            <a:solidFill>
+              <a:srgbClr val="1A73E8"/>
+            </a:solidFill>
+          </a:ln>
+        </p:spPr>
+        <p:style>
+          <a:lnRef idx="1">
+            <a:schemeClr val="accent1"/>
+          </a:lnRef>
+          <a:fillRef idx="3">
+            <a:schemeClr val="accent1"/>
+          </a:fillRef>
+          <a:effectRef idx="2">
+            <a:schemeClr val="accent1"/>
+          </a:effectRef>
+          <a:fontRef idx="minor">
+            <a:schemeClr val="lt1"/>
+          </a:fontRef>
+        </p:style>
+        <p:txBody>
+          <a:bodyPr rtlCol="0" anchor="ctr" wrap="square"/>
+          <a:lstStyle/>
+          <a:p>
+            <a:pPr algn="ctr">
+              <a:defRPr sz="1100" b="1">
+                <a:solidFill>
+                  <a:srgbClr val="1E293B"/>
+                </a:solidFill>
+              </a:defRPr>
+            </a:pPr>
+            <a:r>
+              <a:t>policy_specialist</a:t>
+            </a:r>
+          </a:p>
+        </p:txBody>
+      </p:sp>
+      <p:sp>
+        <p:nvSpPr>
+          <p:cNvPr id="9" name="Diamond 8"/>
+          <p:cNvSpPr/>
+          <p:nvPr/>
+        </p:nvSpPr>
+        <p:spPr>
+          <a:xfrm>
+            <a:off x="1645920" y="4937760"/>
+            <a:ext cx="1828800" cy="548640"/>
+          </a:xfrm>
+          <a:prstGeom prst="diamond">
+            <a:avLst/>
+          </a:prstGeom>
+          <a:solidFill>
+            <a:srgbClr val="FBBC05"/>
+          </a:solidFill>
+          <a:ln w="19050">
+            <a:solidFill>
+              <a:srgbClr val="1A73E8"/>
+            </a:solidFill>
+          </a:ln>
+        </p:spPr>
+        <p:style>
+          <a:lnRef idx="1">
+            <a:schemeClr val="accent1"/>
+          </a:lnRef>
+          <a:fillRef idx="3">
+            <a:schemeClr val="accent1"/>
+          </a:fillRef>
+          <a:effectRef idx="2">
+            <a:schemeClr val="accent1"/>
+          </a:effectRef>
+          <a:fontRef idx="minor">
+            <a:schemeClr val="lt1"/>
+          </a:fontRef>
+        </p:style>
+        <p:txBody>
+          <a:bodyPr rtlCol="0" anchor="ctr" wrap="square"/>
+          <a:lstStyle/>
+          <a:p>
+            <a:pPr algn="ctr">
+              <a:defRPr sz="1100" b="1">
+                <a:solidFill>
+                  <a:srgbClr val="1E293B"/>
+                </a:solidFill>
+              </a:defRPr>
+            </a:pPr>
+            <a:r>
+              <a:t>Policy Gatekeeper (Allow?)</a:t>
+            </a:r>
+          </a:p>
+        </p:txBody>
+      </p:sp>
+      <p:sp>
+        <p:nvSpPr>
+          <p:cNvPr id="10" name="Rounded Rectangle 9"/>
+          <p:cNvSpPr/>
+          <p:nvPr/>
+        </p:nvSpPr>
+        <p:spPr>
+          <a:xfrm>
+            <a:off x="1645920" y="5760720"/>
+            <a:ext cx="1828800" cy="548640"/>
+          </a:xfrm>
+          <a:prstGeom prst="roundRect">
+            <a:avLst/>
+          </a:prstGeom>
+          <a:solidFill>
+            <a:srgbClr val="34A853"/>
+          </a:solidFill>
+          <a:ln w="19050">
+            <a:solidFill>
+              <a:srgbClr val="1A73E8"/>
+            </a:solidFill>
+          </a:ln>
+        </p:spPr>
+        <p:style>
+          <a:lnRef idx="1">
+            <a:schemeClr val="accent1"/>
+          </a:lnRef>
+          <a:fillRef idx="3">
+            <a:schemeClr val="accent1"/>
+          </a:fillRef>
+          <a:effectRef idx="2">
+            <a:schemeClr val="accent1"/>
+          </a:effectRef>
+          <a:fontRef idx="minor">
+            <a:schemeClr val="lt1"/>
+          </a:fontRef>
+        </p:style>
+        <p:txBody>
+          <a:bodyPr rtlCol="0" anchor="ctr" wrap="square"/>
+          <a:lstStyle/>
+          <a:p>
+            <a:pPr algn="ctr">
+              <a:defRPr sz="1100" b="1">
+                <a:solidFill>
+                  <a:srgbClr val="FFFFFF"/>
+                </a:solidFill>
+              </a:defRPr>
+            </a:pPr>
+            <a:r>
+              <a:t>FastMCP (WorkWeek / ITSM)</a:t>
+            </a:r>
+          </a:p>
+        </p:txBody>
+      </p:sp>
+      <p:sp>
+        <p:nvSpPr>
+          <p:cNvPr id="11" name="Rounded Rectangle 10"/>
+          <p:cNvSpPr/>
+          <p:nvPr/>
+        </p:nvSpPr>
+        <p:spPr>
+          <a:xfrm>
+            <a:off x="6400800" y="1645920"/>
+            <a:ext cx="5029200" cy="1005840"/>
           </a:xfrm>
           <a:prstGeom prst="roundRect">
             <a:avLst/>
@@ -7144,14 +7556,14 @@
       </p:sp>
       <p:sp>
         <p:nvSpPr>
-          <p:cNvPr id="5" name="TextBox 4"/>
+          <p:cNvPr id="12" name="TextBox 11"/>
           <p:cNvSpPr txBox="1"/>
           <p:nvPr/>
         </p:nvSpPr>
         <p:spPr>
           <a:xfrm>
-            <a:off x="6858000" y="1554480"/>
-            <a:ext cx="4389120" cy="914400"/>
+            <a:off x="6583680" y="1737360"/>
+            <a:ext cx="4663440" cy="822960"/>
           </a:xfrm>
           <a:prstGeom prst="rect">
             <a:avLst/>
@@ -7168,40 +7580,40 @@
               <a:spcAft>
                 <a:spcPts val="200"/>
               </a:spcAft>
-              <a:defRPr sz="1200" b="1">
+              <a:defRPr sz="1300" b="1">
                 <a:solidFill>
                   <a:srgbClr val="1A73E8"/>
                 </a:solidFill>
               </a:defRPr>
             </a:pPr>
             <a:r>
-              <a:t>Step 1: Ingestion &amp; In-Flight Masking</a:t>
-            </a:r>
-          </a:p>
-          <a:p>
-            <a:pPr>
-              <a:defRPr sz="1000">
-                <a:solidFill>
-                  <a:srgbClr val="1E293B"/>
-                </a:solidFill>
-              </a:defRPr>
-            </a:pPr>
-            <a:r>
-              <a:t>User prompt is intercepted by Model Armor regex filter; NRIC, cards, and credentials are redacted prior to LLM submission.</a:t>
-            </a:r>
-          </a:p>
-        </p:txBody>
-      </p:sp>
-      <p:sp>
-        <p:nvSpPr>
-          <p:cNvPr id="6" name="Rounded Rectangle 5"/>
+              <a:t>1. Security &amp; Identity</a:t>
+            </a:r>
+          </a:p>
+          <a:p>
+            <a:pPr>
+              <a:defRPr sz="1100">
+                <a:solidFill>
+                  <a:srgbClr val="1E293B"/>
+                </a:solidFill>
+              </a:defRPr>
+            </a:pPr>
+            <a:r>
+              <a:t>API Gateway injects Auth. Model Armor blocks prompt injections and masks PII/NRICs.</a:t>
+            </a:r>
+          </a:p>
+        </p:txBody>
+      </p:sp>
+      <p:sp>
+        <p:nvSpPr>
+          <p:cNvPr id="13" name="Rounded Rectangle 12"/>
           <p:cNvSpPr/>
           <p:nvPr/>
         </p:nvSpPr>
         <p:spPr>
           <a:xfrm>
-            <a:off x="6675120" y="2697480"/>
-            <a:ext cx="4754880" cy="1097280"/>
+            <a:off x="6400800" y="2788920"/>
+            <a:ext cx="5029200" cy="1005840"/>
           </a:xfrm>
           <a:prstGeom prst="roundRect">
             <a:avLst/>
@@ -7239,14 +7651,14 @@
       </p:sp>
       <p:sp>
         <p:nvSpPr>
-          <p:cNvPr id="7" name="TextBox 6"/>
+          <p:cNvPr id="14" name="TextBox 13"/>
           <p:cNvSpPr txBox="1"/>
           <p:nvPr/>
         </p:nvSpPr>
         <p:spPr>
           <a:xfrm>
-            <a:off x="6858000" y="2788920"/>
-            <a:ext cx="4389120" cy="914400"/>
+            <a:off x="6583680" y="2880360"/>
+            <a:ext cx="4663440" cy="822960"/>
           </a:xfrm>
           <a:prstGeom prst="rect">
             <a:avLst/>
@@ -7263,40 +7675,40 @@
               <a:spcAft>
                 <a:spcPts val="200"/>
               </a:spcAft>
-              <a:defRPr sz="1200" b="1">
+              <a:defRPr sz="1300" b="1">
                 <a:solidFill>
                   <a:srgbClr val="1A73E8"/>
                 </a:solidFill>
               </a:defRPr>
             </a:pPr>
             <a:r>
-              <a:t>Step 2: Orchestrator Intent Decomposition</a:t>
-            </a:r>
-          </a:p>
-          <a:p>
-            <a:pPr>
-              <a:defRPr sz="1000">
-                <a:solidFill>
-                  <a:srgbClr val="1E293B"/>
-                </a:solidFill>
-              </a:defRPr>
-            </a:pPr>
-            <a:r>
-              <a:t>Root agent analyzes query (e.g. 'I need 2 days leave and a ticket to forward emails') and decomposes into parallel/sequential sub-tasks.</a:t>
-            </a:r>
-          </a:p>
-        </p:txBody>
-      </p:sp>
-      <p:sp>
-        <p:nvSpPr>
-          <p:cNvPr id="8" name="Rounded Rectangle 7"/>
+              <a:t>2. Agentic Routing</a:t>
+            </a:r>
+          </a:p>
+          <a:p>
+            <a:pPr>
+              <a:defRPr sz="1100">
+                <a:solidFill>
+                  <a:srgbClr val="1E293B"/>
+                </a:solidFill>
+              </a:defRPr>
+            </a:pPr>
+            <a:r>
+              <a:t>Orchestrator acts as the brain, determining intent and parallelizing tasks to sub-agents.</a:t>
+            </a:r>
+          </a:p>
+        </p:txBody>
+      </p:sp>
+      <p:sp>
+        <p:nvSpPr>
+          <p:cNvPr id="15" name="Rounded Rectangle 14"/>
           <p:cNvSpPr/>
           <p:nvPr/>
         </p:nvSpPr>
         <p:spPr>
           <a:xfrm>
-            <a:off x="6675120" y="3931920"/>
-            <a:ext cx="4754880" cy="1097280"/>
+            <a:off x="6400800" y="3931920"/>
+            <a:ext cx="5029200" cy="1005840"/>
           </a:xfrm>
           <a:prstGeom prst="roundRect">
             <a:avLst/>
@@ -7334,14 +7746,14 @@
       </p:sp>
       <p:sp>
         <p:nvSpPr>
-          <p:cNvPr id="9" name="TextBox 8"/>
+          <p:cNvPr id="16" name="TextBox 15"/>
           <p:cNvSpPr txBox="1"/>
           <p:nvPr/>
         </p:nvSpPr>
         <p:spPr>
           <a:xfrm>
-            <a:off x="6858000" y="4023360"/>
-            <a:ext cx="4389120" cy="914400"/>
+            <a:off x="6583680" y="4023360"/>
+            <a:ext cx="4663440" cy="822960"/>
           </a:xfrm>
           <a:prstGeom prst="rect">
             <a:avLst/>
@@ -7358,40 +7770,40 @@
               <a:spcAft>
                 <a:spcPts val="200"/>
               </a:spcAft>
-              <a:defRPr sz="1200" b="1">
+              <a:defRPr sz="1300" b="1">
                 <a:solidFill>
                   <a:srgbClr val="1A73E8"/>
                 </a:solidFill>
               </a:defRPr>
             </a:pPr>
             <a:r>
-              <a:t>Step 3: Specialist Tool Invocation</a:t>
-            </a:r>
-          </a:p>
-          <a:p>
-            <a:pPr>
-              <a:defRPr sz="1000">
-                <a:solidFill>
-                  <a:srgbClr val="1E293B"/>
-                </a:solidFill>
-              </a:defRPr>
-            </a:pPr>
-            <a:r>
-              <a:t>Policy Specialist verifies notice rules -&gt; HCM Specialist books time off -&gt; ITSM Specialist creates email routing incident.</a:t>
-            </a:r>
-          </a:p>
-        </p:txBody>
-      </p:sp>
-      <p:sp>
-        <p:nvSpPr>
-          <p:cNvPr id="10" name="Rounded Rectangle 9"/>
+              <a:t>3. Policy Gatekeeper</a:t>
+            </a:r>
+          </a:p>
+          <a:p>
+            <a:pPr>
+              <a:defRPr sz="1100">
+                <a:solidFill>
+                  <a:srgbClr val="1E293B"/>
+                </a:solidFill>
+              </a:defRPr>
+            </a:pPr>
+            <a:r>
+              <a:t>Crucial constraint step: Sub-agents mathematically verify rules (e.g. 15-day notice) BEFORE taking any action. Denies non-compliant requests.</a:t>
+            </a:r>
+          </a:p>
+        </p:txBody>
+      </p:sp>
+      <p:sp>
+        <p:nvSpPr>
+          <p:cNvPr id="17" name="Rounded Rectangle 16"/>
           <p:cNvSpPr/>
           <p:nvPr/>
         </p:nvSpPr>
         <p:spPr>
           <a:xfrm>
-            <a:off x="6675120" y="5166360"/>
-            <a:ext cx="4754880" cy="1097280"/>
+            <a:off x="6400800" y="5074920"/>
+            <a:ext cx="5029200" cy="1005840"/>
           </a:xfrm>
           <a:prstGeom prst="roundRect">
             <a:avLst/>
@@ -7429,14 +7841,14 @@
       </p:sp>
       <p:sp>
         <p:nvSpPr>
-          <p:cNvPr id="11" name="TextBox 10"/>
+          <p:cNvPr id="18" name="TextBox 17"/>
           <p:cNvSpPr txBox="1"/>
           <p:nvPr/>
         </p:nvSpPr>
         <p:spPr>
           <a:xfrm>
-            <a:off x="6858000" y="5257800"/>
-            <a:ext cx="4389120" cy="914400"/>
+            <a:off x="6583680" y="5166360"/>
+            <a:ext cx="4663440" cy="822960"/>
           </a:xfrm>
           <a:prstGeom prst="rect">
             <a:avLst/>
@@ -7453,26 +7865,26 @@
               <a:spcAft>
                 <a:spcPts val="200"/>
               </a:spcAft>
-              <a:defRPr sz="1200" b="1">
+              <a:defRPr sz="1300" b="1">
                 <a:solidFill>
                   <a:srgbClr val="1A73E8"/>
                 </a:solidFill>
               </a:defRPr>
             </a:pPr>
             <a:r>
-              <a:t>Step 4: Synthesis, Citation &amp; UI Stream</a:t>
-            </a:r>
-          </a:p>
-          <a:p>
-            <a:pPr>
-              <a:defRPr sz="1000">
-                <a:solidFill>
-                  <a:srgbClr val="1E293B"/>
-                </a:solidFill>
-              </a:defRPr>
-            </a:pPr>
-            <a:r>
-              <a:t>Results are collated with ticket IDs, balance confirmations, and bottom policy sources, streamed back to user in sub-second response.</a:t>
+              <a:t>4. Service Integration (FastMCP)</a:t>
+            </a:r>
+          </a:p>
+          <a:p>
+            <a:pPr>
+              <a:defRPr sz="1100">
+                <a:solidFill>
+                  <a:srgbClr val="1E293B"/>
+                </a:solidFill>
+              </a:defRPr>
+            </a:pPr>
+            <a:r>
+              <a:t>Allowed actions are executed against Mock SaaS (WorkWeek/ServiceImmediately) using context-injected Auth tokens.</a:t>
             </a:r>
           </a:p>
         </p:txBody>

</xml_diff>